<commit_message>
updated with protocols used between the hosts
Co-Authored-By: Claude Sonnet 4.6 <noreply@anthropic.com>
</commit_message>
<xml_diff>
--- a/docs/Perf Test Harness-Overview-2026.pptx
+++ b/docs/Perf Test Harness-Overview-2026.pptx
@@ -260,7 +260,7 @@
           <a:p>
             <a:fld id="{D18AAD14-9C34-4AA5-B94E-6692F6349C36}" type="datetimeFigureOut">
               <a:rPr lang="en-US" smtClean="0"/>
-              <a:t>5/5/2026</a:t>
+              <a:t>5/26/2026</a:t>
             </a:fld>
             <a:endParaRPr lang="en-US"/>
           </a:p>
@@ -28138,6 +28138,78 @@
           </a:p>
         </p:txBody>
       </p:sp>
+      <p:sp>
+        <p:nvSpPr>
+          <p:cNvPr id="3" name="TextBox 2">
+            <a:extLst>
+              <a:ext uri="{FF2B5EF4-FFF2-40B4-BE49-F238E27FC236}">
+                <a16:creationId xmlns:a16="http://schemas.microsoft.com/office/drawing/2014/main" id="{7C22E9C6-96EF-69E3-6D58-2ED0D45D5DE2}"/>
+              </a:ext>
+            </a:extLst>
+          </p:cNvPr>
+          <p:cNvSpPr txBox="1"/>
+          <p:nvPr/>
+        </p:nvSpPr>
+        <p:spPr>
+          <a:xfrm>
+            <a:off x="6600000" y="1076716"/>
+            <a:ext cx="388938" cy="161043"/>
+          </a:xfrm>
+          <a:prstGeom prst="rect">
+            <a:avLst/>
+          </a:prstGeom>
+          <a:noFill/>
+        </p:spPr>
+        <p:txBody>
+          <a:bodyPr wrap="square" lIns="0" tIns="0" rIns="0" bIns="0" rtlCol="0">
+            <a:noAutofit/>
+          </a:bodyPr>
+          <a:lstStyle/>
+          <a:p>
+            <a:pPr algn="l"/>
+            <a:r>
+              <a:rPr lang="en-GB" sz="1600" dirty="0"/>
+              <a:t>SSH</a:t>
+            </a:r>
+          </a:p>
+        </p:txBody>
+      </p:sp>
+      <p:sp>
+        <p:nvSpPr>
+          <p:cNvPr id="4" name="TextBox 3">
+            <a:extLst>
+              <a:ext uri="{FF2B5EF4-FFF2-40B4-BE49-F238E27FC236}">
+                <a16:creationId xmlns:a16="http://schemas.microsoft.com/office/drawing/2014/main" id="{7247D29F-8495-2BBC-B37B-3CEF1215021A}"/>
+              </a:ext>
+            </a:extLst>
+          </p:cNvPr>
+          <p:cNvSpPr txBox="1"/>
+          <p:nvPr/>
+        </p:nvSpPr>
+        <p:spPr>
+          <a:xfrm>
+            <a:off x="9109474" y="1403919"/>
+            <a:ext cx="442526" cy="153082"/>
+          </a:xfrm>
+          <a:prstGeom prst="rect">
+            <a:avLst/>
+          </a:prstGeom>
+          <a:noFill/>
+        </p:spPr>
+        <p:txBody>
+          <a:bodyPr wrap="square" lIns="0" tIns="0" rIns="0" bIns="0" rtlCol="0">
+            <a:noAutofit/>
+          </a:bodyPr>
+          <a:lstStyle/>
+          <a:p>
+            <a:pPr algn="l"/>
+            <a:r>
+              <a:rPr lang="en-GB" sz="1600" dirty="0"/>
+              <a:t>SMF</a:t>
+            </a:r>
+          </a:p>
+        </p:txBody>
+      </p:sp>
     </p:spTree>
     <p:extLst>
       <p:ext uri="{BB962C8B-B14F-4D97-AF65-F5344CB8AC3E}">
@@ -31820,15 +31892,6 @@
 </file>
 
 <file path=customXml/item2.xml><?xml version="1.0" encoding="utf-8"?>
-<?mso-contentType ?>
-<FormTemplates xmlns="http://schemas.microsoft.com/sharepoint/v3/contenttype/forms">
-  <Display>DocumentLibraryForm</Display>
-  <Edit>DocumentLibraryForm</Edit>
-  <New>DocumentLibraryForm</New>
-</FormTemplates>
-</file>
-
-<file path=customXml/item3.xml><?xml version="1.0" encoding="utf-8"?>
 <ct:contentTypeSchema xmlns:ct="http://schemas.microsoft.com/office/2006/metadata/contentType" xmlns:ma="http://schemas.microsoft.com/office/2006/metadata/properties/metaAttributes" ct:_="" ma:_="" ma:contentTypeName="Document" ma:contentTypeID="0x010100DBA59E3993B10E4CAD93B4C6B6AB4338" ma:contentTypeVersion="18" ma:contentTypeDescription="Create a new document." ma:contentTypeScope="" ma:versionID="b1c352a0e645668a65a42d6a36924e0e">
   <xsd:schema xmlns:xsd="http://www.w3.org/2001/XMLSchema" xmlns:xs="http://www.w3.org/2001/XMLSchema" xmlns:p="http://schemas.microsoft.com/office/2006/metadata/properties" xmlns:ns2="b9684263-5219-44dc-8ace-9e9cf51448b5" xmlns:ns3="c50c4712-2507-4635-8d96-ac0f8ed1146c" targetNamespace="http://schemas.microsoft.com/office/2006/metadata/properties" ma:root="true" ma:fieldsID="0ebac1cb52d4c4ca9196d097ceac5630" ns2:_="" ns3:_="">
     <xsd:import namespace="b9684263-5219-44dc-8ace-9e9cf51448b5"/>
@@ -32083,6 +32146,15 @@
 </ct:contentTypeSchema>
 </file>
 
+<file path=customXml/item3.xml><?xml version="1.0" encoding="utf-8"?>
+<?mso-contentType ?>
+<FormTemplates xmlns="http://schemas.microsoft.com/sharepoint/v3/contenttype/forms">
+  <Display>DocumentLibraryForm</Display>
+  <Edit>DocumentLibraryForm</Edit>
+  <New>DocumentLibraryForm</New>
+</FormTemplates>
+</file>
+
 <file path=customXml/itemProps1.xml><?xml version="1.0" encoding="utf-8"?>
 <ds:datastoreItem xmlns:ds="http://schemas.openxmlformats.org/officeDocument/2006/customXml" ds:itemID="{33471C70-1727-4A93-A528-B2FB0F1E4E8F}">
   <ds:schemaRefs>
@@ -32101,14 +32173,6 @@
 </file>
 
 <file path=customXml/itemProps2.xml><?xml version="1.0" encoding="utf-8"?>
-<ds:datastoreItem xmlns:ds="http://schemas.openxmlformats.org/officeDocument/2006/customXml" ds:itemID="{79AF0659-183A-43C2-AA7B-C08381F298CB}">
-  <ds:schemaRefs>
-    <ds:schemaRef ds:uri="http://schemas.microsoft.com/sharepoint/v3/contenttype/forms"/>
-  </ds:schemaRefs>
-</ds:datastoreItem>
-</file>
-
-<file path=customXml/itemProps3.xml><?xml version="1.0" encoding="utf-8"?>
 <ds:datastoreItem xmlns:ds="http://schemas.openxmlformats.org/officeDocument/2006/customXml" ds:itemID="{C5590A90-ABCF-443C-A154-8FE4DFA404C4}">
   <ds:schemaRefs>
     <ds:schemaRef ds:uri="http://schemas.microsoft.com/office/2006/metadata/contentType"/>
@@ -32125,4 +32189,12 @@
     <ds:schemaRef ds:uri="http://schemas.microsoft.com/internal/obd"/>
   </ds:schemaRefs>
 </ds:datastoreItem>
+</file>
+
+<file path=customXml/itemProps3.xml><?xml version="1.0" encoding="utf-8"?>
+<ds:datastoreItem xmlns:ds="http://schemas.openxmlformats.org/officeDocument/2006/customXml" ds:itemID="{79AF0659-183A-43C2-AA7B-C08381F298CB}">
+  <ds:schemaRefs>
+    <ds:schemaRef ds:uri="http://schemas.microsoft.com/sharepoint/v3/contenttype/forms"/>
+  </ds:schemaRefs>
+</ds:datastoreItem>
 </file>
</xml_diff>